<commit_message>
Added session 15 slides
</commit_message>
<xml_diff>
--- a/Session 14/Session14_Transformers_Attention.pptx
+++ b/Session 14/Session14_Transformers_Attention.pptx
@@ -24461,7 +24461,7 @@
         </p:nvSpPr>
         <p:spPr>
           <a:xfrm>
-            <a:off x="1645920" y="3291840"/>
+            <a:off x="2397034" y="3291840"/>
             <a:ext cx="27432" cy="502920"/>
           </a:xfrm>
           <a:prstGeom prst="rect">
@@ -24486,7 +24486,7 @@
         </p:nvSpPr>
         <p:spPr>
           <a:xfrm>
-            <a:off x="3017520" y="3291840"/>
+            <a:off x="3768634" y="3291840"/>
             <a:ext cx="27432" cy="502920"/>
           </a:xfrm>
           <a:prstGeom prst="rect">
@@ -24511,7 +24511,7 @@
         </p:nvSpPr>
         <p:spPr>
           <a:xfrm>
-            <a:off x="1673352" y="3749040"/>
+            <a:off x="2424466" y="3775164"/>
             <a:ext cx="1371600" cy="27432"/>
           </a:xfrm>
           <a:prstGeom prst="rect">

</xml_diff>